<commit_message>
Update BANK LOGO DOCUMENT 800x250 and 8 other files
</commit_message>
<xml_diff>
--- a/參賽準備/參賽文件/SQL_SPA_Tools_競賽簡報.pptx
+++ b/參賽準備/參賽文件/SQL_SPA_Tools_競賽簡報.pptx
@@ -4643,6 +4643,108 @@
           </a:p>
         </p:txBody>
       </p:sp>
+      <p:sp>
+        <p:nvSpPr>
+          <p:cNvPr id="10" name="LogoBackground">
+            <a:extLst>
+              <a:ext uri="{FF2B5EF4-FFF2-40B4-BE49-F238E27FC236}">
+                <a16:creationId xmlns:a16="http://schemas.microsoft.com/office/drawing/2014/main" id="{21CBEDEE-312E-5131-D295-6E9D1870ABA2}"/>
+              </a:ext>
+            </a:extLst>
+          </p:cNvPr>
+          <p:cNvSpPr/>
+          <p:nvPr/>
+        </p:nvSpPr>
+        <p:spPr>
+          <a:xfrm>
+            <a:off x="8064500" y="1587500"/>
+            <a:ext cx="3746500" cy="1333500"/>
+          </a:xfrm>
+          <a:prstGeom prst="rect">
+            <a:avLst/>
+          </a:prstGeom>
+          <a:solidFill>
+            <a:srgbClr val="F7FAFC"/>
+          </a:solidFill>
+          <a:ln w="19050">
+            <a:noFill/>
+            <a:prstDash val="solid"/>
+          </a:ln>
+          <a:effectLst/>
+          <a:extLst>
+            <a:ext uri="{91240B29-F687-4F45-9708-019B960494DF}">
+              <a14:hiddenLine xmlns:a14="http://schemas.microsoft.com/office/drawing/2010/main" w="19050">
+                <a:solidFill>
+                  <a:schemeClr val="accent1">
+                    <a:shade val="15000"/>
+                  </a:schemeClr>
+                </a:solidFill>
+                <a:prstDash val="solid"/>
+              </a14:hiddenLine>
+            </a:ext>
+          </a:extLst>
+        </p:spPr>
+        <p:style>
+          <a:lnRef idx="2">
+            <a:schemeClr val="accent1">
+              <a:shade val="15000"/>
+            </a:schemeClr>
+          </a:lnRef>
+          <a:fillRef idx="1">
+            <a:schemeClr val="accent1"/>
+          </a:fillRef>
+          <a:effectRef idx="0">
+            <a:schemeClr val="accent1"/>
+          </a:effectRef>
+          <a:fontRef idx="minor">
+            <a:schemeClr val="lt1"/>
+          </a:fontRef>
+        </p:style>
+        <p:txBody>
+          <a:bodyPr rtlCol="0" anchor="ctr"/>
+          <a:lstStyle/>
+          <a:p>
+            <a:pPr algn="ctr"/>
+            <a:endParaRPr lang="zh-TW" altLang="en-US"/>
+          </a:p>
+        </p:txBody>
+      </p:sp>
+      <p:pic>
+        <p:nvPicPr>
+          <p:cNvPr id="12" name="LockholderBankLogo">
+            <a:extLst>
+              <a:ext uri="{FF2B5EF4-FFF2-40B4-BE49-F238E27FC236}">
+                <a16:creationId xmlns:a16="http://schemas.microsoft.com/office/drawing/2014/main" id="{9C3821F0-FA7F-41FC-8094-E1CF6499AD8C}"/>
+              </a:ext>
+            </a:extLst>
+          </p:cNvPr>
+          <p:cNvPicPr>
+            <a:picLocks noChangeAspect="1"/>
+          </p:cNvPicPr>
+          <p:nvPr/>
+        </p:nvPicPr>
+        <p:blipFill>
+          <a:blip r:embed="rId3">
+            <a:extLst>
+              <a:ext uri="{28A0092B-C50C-407E-A947-70E740481C1C}">
+                <a14:useLocalDpi xmlns:a14="http://schemas.microsoft.com/office/drawing/2010/main" val="0"/>
+              </a:ext>
+            </a:extLst>
+          </a:blip>
+          <a:stretch>
+            <a:fillRect/>
+          </a:stretch>
+        </p:blipFill>
+        <p:spPr>
+          <a:xfrm>
+            <a:off x="8216900" y="1765300"/>
+            <a:ext cx="3441700" cy="1075563"/>
+          </a:xfrm>
+          <a:prstGeom prst="rect">
+            <a:avLst/>
+          </a:prstGeom>
+        </p:spPr>
+      </p:pic>
     </p:spTree>
     <p:extLst>
       <p:ext uri="{BB962C8B-B14F-4D97-AF65-F5344CB8AC3E}">

</xml_diff>